<commit_message>
docs: update badge link repo GitHub Zeinkunn/RCA-Test
</commit_message>
<xml_diff>
--- a/RCA_Presentasi_Tugas_AP.pptx
+++ b/RCA_Presentasi_Tugas_AP.pptx
@@ -5,24 +5,24 @@
     <p:sldMasterId id="2147483648" r:id="rId1"/>
   </p:sldMasterIdLst>
   <p:sldIdLst>
-    <p:sldId id="256" r:id="rId7"/>
-    <p:sldId id="257" r:id="rId8"/>
-    <p:sldId id="258" r:id="rId9"/>
-    <p:sldId id="259" r:id="rId10"/>
-    <p:sldId id="260" r:id="rId11"/>
-    <p:sldId id="261" r:id="rId12"/>
-    <p:sldId id="262" r:id="rId13"/>
-    <p:sldId id="263" r:id="rId14"/>
-    <p:sldId id="264" r:id="rId15"/>
-    <p:sldId id="265" r:id="rId16"/>
-    <p:sldId id="266" r:id="rId17"/>
-    <p:sldId id="267" r:id="rId18"/>
-    <p:sldId id="268" r:id="rId19"/>
-    <p:sldId id="269" r:id="rId20"/>
-    <p:sldId id="270" r:id="rId21"/>
-    <p:sldId id="271" r:id="rId22"/>
+    <p:sldId id="256" r:id="rId2"/>
+    <p:sldId id="257" r:id="rId3"/>
+    <p:sldId id="258" r:id="rId4"/>
+    <p:sldId id="259" r:id="rId5"/>
+    <p:sldId id="260" r:id="rId6"/>
+    <p:sldId id="261" r:id="rId7"/>
+    <p:sldId id="262" r:id="rId8"/>
+    <p:sldId id="263" r:id="rId9"/>
+    <p:sldId id="264" r:id="rId10"/>
+    <p:sldId id="265" r:id="rId11"/>
+    <p:sldId id="266" r:id="rId12"/>
+    <p:sldId id="267" r:id="rId13"/>
+    <p:sldId id="268" r:id="rId14"/>
+    <p:sldId id="269" r:id="rId15"/>
+    <p:sldId id="270" r:id="rId16"/>
+    <p:sldId id="271" r:id="rId17"/>
   </p:sldIdLst>
-  <p:sldSz cx="12191695" cy="6858000" type="screen4x3"/>
+  <p:sldSz cx="12192000" cy="6858000"/>
   <p:notesSz cx="6858000" cy="9144000"/>
   <p:defaultTextStyle>
     <a:defPPr>
@@ -119,6 +119,22 @@
       </a:defRPr>
     </a:lvl9pPr>
   </p:defaultTextStyle>
+  <p:extLst>
+    <p:ext uri="{EFAFB233-063F-42B5-8137-9DF3F51BA10A}">
+      <p15:sldGuideLst xmlns:p15="http://schemas.microsoft.com/office/powerpoint/2012/main">
+        <p15:guide id="1" orient="horz" pos="2160">
+          <p15:clr>
+            <a:srgbClr val="A4A3A4"/>
+          </p15:clr>
+        </p15:guide>
+        <p15:guide id="2" pos="2880">
+          <p15:clr>
+            <a:srgbClr val="A4A3A4"/>
+          </p15:clr>
+        </p15:guide>
+      </p15:sldGuideLst>
+    </p:ext>
+  </p:extLst>
 </p:presentation>
 </file>
 
@@ -160,10 +176,9 @@
           <a:lstStyle/>
           <a:p>
             <a:r>
-              <a:rPr lang="en-US" smtClean="0"/>
+              <a:rPr lang="en-US"/>
               <a:t>Click to edit Master title style</a:t>
             </a:r>
-            <a:endParaRPr lang="en-US"/>
           </a:p>
         </p:txBody>
       </p:sp>
@@ -279,10 +294,9 @@
           </a:lstStyle>
           <a:p>
             <a:r>
-              <a:rPr lang="en-US" smtClean="0"/>
+              <a:rPr lang="en-US"/>
               <a:t>Click to edit Master subtitle style</a:t>
             </a:r>
-            <a:endParaRPr lang="en-US"/>
           </a:p>
         </p:txBody>
       </p:sp>
@@ -303,7 +317,7 @@
           <a:p>
             <a:fld id="{5BCAD085-E8A6-8845-BD4E-CB4CCA059FC4}" type="datetimeFigureOut">
               <a:rPr lang="en-US" smtClean="0"/>
-              <a:t>1/27/13</a:t>
+              <a:t>10/7/2026</a:t>
             </a:fld>
             <a:endParaRPr lang="en-US"/>
           </a:p>
@@ -397,10 +411,9 @@
           <a:lstStyle/>
           <a:p>
             <a:r>
-              <a:rPr lang="en-US" smtClean="0"/>
+              <a:rPr lang="en-US"/>
               <a:t>Click to edit Master title style</a:t>
             </a:r>
-            <a:endParaRPr lang="en-US"/>
           </a:p>
         </p:txBody>
       </p:sp>
@@ -421,38 +434,37 @@
           <a:p>
             <a:pPr lvl="0"/>
             <a:r>
-              <a:rPr lang="en-US" smtClean="0"/>
+              <a:rPr lang="en-US"/>
               <a:t>Click to edit Master text styles</a:t>
             </a:r>
           </a:p>
           <a:p>
             <a:pPr lvl="1"/>
             <a:r>
-              <a:rPr lang="en-US" smtClean="0"/>
+              <a:rPr lang="en-US"/>
               <a:t>Second level</a:t>
             </a:r>
           </a:p>
           <a:p>
             <a:pPr lvl="2"/>
             <a:r>
-              <a:rPr lang="en-US" smtClean="0"/>
+              <a:rPr lang="en-US"/>
               <a:t>Third level</a:t>
             </a:r>
           </a:p>
           <a:p>
             <a:pPr lvl="3"/>
             <a:r>
-              <a:rPr lang="en-US" smtClean="0"/>
+              <a:rPr lang="en-US"/>
               <a:t>Fourth level</a:t>
             </a:r>
           </a:p>
           <a:p>
             <a:pPr lvl="4"/>
             <a:r>
-              <a:rPr lang="en-US" smtClean="0"/>
+              <a:rPr lang="en-US"/>
               <a:t>Fifth level</a:t>
             </a:r>
-            <a:endParaRPr lang="en-US"/>
           </a:p>
         </p:txBody>
       </p:sp>
@@ -473,7 +485,7 @@
           <a:p>
             <a:fld id="{5BCAD085-E8A6-8845-BD4E-CB4CCA059FC4}" type="datetimeFigureOut">
               <a:rPr lang="en-US" smtClean="0"/>
-              <a:t>1/27/13</a:t>
+              <a:t>10/7/2026</a:t>
             </a:fld>
             <a:endParaRPr lang="en-US"/>
           </a:p>
@@ -572,10 +584,9 @@
           <a:lstStyle/>
           <a:p>
             <a:r>
-              <a:rPr lang="en-US" smtClean="0"/>
+              <a:rPr lang="en-US"/>
               <a:t>Click to edit Master title style</a:t>
             </a:r>
-            <a:endParaRPr lang="en-US"/>
           </a:p>
         </p:txBody>
       </p:sp>
@@ -601,38 +612,37 @@
           <a:p>
             <a:pPr lvl="0"/>
             <a:r>
-              <a:rPr lang="en-US" smtClean="0"/>
+              <a:rPr lang="en-US"/>
               <a:t>Click to edit Master text styles</a:t>
             </a:r>
           </a:p>
           <a:p>
             <a:pPr lvl="1"/>
             <a:r>
-              <a:rPr lang="en-US" smtClean="0"/>
+              <a:rPr lang="en-US"/>
               <a:t>Second level</a:t>
             </a:r>
           </a:p>
           <a:p>
             <a:pPr lvl="2"/>
             <a:r>
-              <a:rPr lang="en-US" smtClean="0"/>
+              <a:rPr lang="en-US"/>
               <a:t>Third level</a:t>
             </a:r>
           </a:p>
           <a:p>
             <a:pPr lvl="3"/>
             <a:r>
-              <a:rPr lang="en-US" smtClean="0"/>
+              <a:rPr lang="en-US"/>
               <a:t>Fourth level</a:t>
             </a:r>
           </a:p>
           <a:p>
             <a:pPr lvl="4"/>
             <a:r>
-              <a:rPr lang="en-US" smtClean="0"/>
+              <a:rPr lang="en-US"/>
               <a:t>Fifth level</a:t>
             </a:r>
-            <a:endParaRPr lang="en-US"/>
           </a:p>
         </p:txBody>
       </p:sp>
@@ -653,7 +663,7 @@
           <a:p>
             <a:fld id="{5BCAD085-E8A6-8845-BD4E-CB4CCA059FC4}" type="datetimeFigureOut">
               <a:rPr lang="en-US" smtClean="0"/>
-              <a:t>1/27/13</a:t>
+              <a:t>10/7/2026</a:t>
             </a:fld>
             <a:endParaRPr lang="en-US"/>
           </a:p>
@@ -747,10 +757,9 @@
           <a:lstStyle/>
           <a:p>
             <a:r>
-              <a:rPr lang="en-US" smtClean="0"/>
+              <a:rPr lang="en-US"/>
               <a:t>Click to edit Master title style</a:t>
             </a:r>
-            <a:endParaRPr lang="en-US"/>
           </a:p>
         </p:txBody>
       </p:sp>
@@ -771,38 +780,37 @@
           <a:p>
             <a:pPr lvl="0"/>
             <a:r>
-              <a:rPr lang="en-US" smtClean="0"/>
+              <a:rPr lang="en-US"/>
               <a:t>Click to edit Master text styles</a:t>
             </a:r>
           </a:p>
           <a:p>
             <a:pPr lvl="1"/>
             <a:r>
-              <a:rPr lang="en-US" smtClean="0"/>
+              <a:rPr lang="en-US"/>
               <a:t>Second level</a:t>
             </a:r>
           </a:p>
           <a:p>
             <a:pPr lvl="2"/>
             <a:r>
-              <a:rPr lang="en-US" smtClean="0"/>
+              <a:rPr lang="en-US"/>
               <a:t>Third level</a:t>
             </a:r>
           </a:p>
           <a:p>
             <a:pPr lvl="3"/>
             <a:r>
-              <a:rPr lang="en-US" smtClean="0"/>
+              <a:rPr lang="en-US"/>
               <a:t>Fourth level</a:t>
             </a:r>
           </a:p>
           <a:p>
             <a:pPr lvl="4"/>
             <a:r>
-              <a:rPr lang="en-US" smtClean="0"/>
+              <a:rPr lang="en-US"/>
               <a:t>Fifth level</a:t>
             </a:r>
-            <a:endParaRPr lang="en-US"/>
           </a:p>
         </p:txBody>
       </p:sp>
@@ -823,7 +831,7 @@
           <a:p>
             <a:fld id="{5BCAD085-E8A6-8845-BD4E-CB4CCA059FC4}" type="datetimeFigureOut">
               <a:rPr lang="en-US" smtClean="0"/>
-              <a:t>1/27/13</a:t>
+              <a:t>10/7/2026</a:t>
             </a:fld>
             <a:endParaRPr lang="en-US"/>
           </a:p>
@@ -926,10 +934,9 @@
           </a:lstStyle>
           <a:p>
             <a:r>
-              <a:rPr lang="en-US" smtClean="0"/>
+              <a:rPr lang="en-US"/>
               <a:t>Click to edit Master title style</a:t>
             </a:r>
-            <a:endParaRPr lang="en-US"/>
           </a:p>
         </p:txBody>
       </p:sp>
@@ -1046,7 +1053,7 @@
           <a:p>
             <a:pPr lvl="0"/>
             <a:r>
-              <a:rPr lang="en-US" smtClean="0"/>
+              <a:rPr lang="en-US"/>
               <a:t>Click to edit Master text styles</a:t>
             </a:r>
           </a:p>
@@ -1069,7 +1076,7 @@
           <a:p>
             <a:fld id="{5BCAD085-E8A6-8845-BD4E-CB4CCA059FC4}" type="datetimeFigureOut">
               <a:rPr lang="en-US" smtClean="0"/>
-              <a:t>1/27/13</a:t>
+              <a:t>10/7/2026</a:t>
             </a:fld>
             <a:endParaRPr lang="en-US"/>
           </a:p>
@@ -1163,10 +1170,9 @@
           <a:lstStyle/>
           <a:p>
             <a:r>
-              <a:rPr lang="en-US" smtClean="0"/>
+              <a:rPr lang="en-US"/>
               <a:t>Click to edit Master title style</a:t>
             </a:r>
-            <a:endParaRPr lang="en-US"/>
           </a:p>
         </p:txBody>
       </p:sp>
@@ -1220,38 +1226,37 @@
           <a:p>
             <a:pPr lvl="0"/>
             <a:r>
-              <a:rPr lang="en-US" smtClean="0"/>
+              <a:rPr lang="en-US"/>
               <a:t>Click to edit Master text styles</a:t>
             </a:r>
           </a:p>
           <a:p>
             <a:pPr lvl="1"/>
             <a:r>
-              <a:rPr lang="en-US" smtClean="0"/>
+              <a:rPr lang="en-US"/>
               <a:t>Second level</a:t>
             </a:r>
           </a:p>
           <a:p>
             <a:pPr lvl="2"/>
             <a:r>
-              <a:rPr lang="en-US" smtClean="0"/>
+              <a:rPr lang="en-US"/>
               <a:t>Third level</a:t>
             </a:r>
           </a:p>
           <a:p>
             <a:pPr lvl="3"/>
             <a:r>
-              <a:rPr lang="en-US" smtClean="0"/>
+              <a:rPr lang="en-US"/>
               <a:t>Fourth level</a:t>
             </a:r>
           </a:p>
           <a:p>
             <a:pPr lvl="4"/>
             <a:r>
-              <a:rPr lang="en-US" smtClean="0"/>
+              <a:rPr lang="en-US"/>
               <a:t>Fifth level</a:t>
             </a:r>
-            <a:endParaRPr lang="en-US"/>
           </a:p>
         </p:txBody>
       </p:sp>
@@ -1305,38 +1310,37 @@
           <a:p>
             <a:pPr lvl="0"/>
             <a:r>
-              <a:rPr lang="en-US" smtClean="0"/>
+              <a:rPr lang="en-US"/>
               <a:t>Click to edit Master text styles</a:t>
             </a:r>
           </a:p>
           <a:p>
             <a:pPr lvl="1"/>
             <a:r>
-              <a:rPr lang="en-US" smtClean="0"/>
+              <a:rPr lang="en-US"/>
               <a:t>Second level</a:t>
             </a:r>
           </a:p>
           <a:p>
             <a:pPr lvl="2"/>
             <a:r>
-              <a:rPr lang="en-US" smtClean="0"/>
+              <a:rPr lang="en-US"/>
               <a:t>Third level</a:t>
             </a:r>
           </a:p>
           <a:p>
             <a:pPr lvl="3"/>
             <a:r>
-              <a:rPr lang="en-US" smtClean="0"/>
+              <a:rPr lang="en-US"/>
               <a:t>Fourth level</a:t>
             </a:r>
           </a:p>
           <a:p>
             <a:pPr lvl="4"/>
             <a:r>
-              <a:rPr lang="en-US" smtClean="0"/>
+              <a:rPr lang="en-US"/>
               <a:t>Fifth level</a:t>
             </a:r>
-            <a:endParaRPr lang="en-US"/>
           </a:p>
         </p:txBody>
       </p:sp>
@@ -1357,7 +1361,7 @@
           <a:p>
             <a:fld id="{5BCAD085-E8A6-8845-BD4E-CB4CCA059FC4}" type="datetimeFigureOut">
               <a:rPr lang="en-US" smtClean="0"/>
-              <a:t>1/27/13</a:t>
+              <a:t>10/7/2026</a:t>
             </a:fld>
             <a:endParaRPr lang="en-US"/>
           </a:p>
@@ -1455,10 +1459,9 @@
           </a:lstStyle>
           <a:p>
             <a:r>
-              <a:rPr lang="en-US" smtClean="0"/>
+              <a:rPr lang="en-US"/>
               <a:t>Click to edit Master title style</a:t>
             </a:r>
-            <a:endParaRPr lang="en-US"/>
           </a:p>
         </p:txBody>
       </p:sp>
@@ -1521,7 +1524,7 @@
           <a:p>
             <a:pPr lvl="0"/>
             <a:r>
-              <a:rPr lang="en-US" smtClean="0"/>
+              <a:rPr lang="en-US"/>
               <a:t>Click to edit Master text styles</a:t>
             </a:r>
           </a:p>
@@ -1577,38 +1580,37 @@
           <a:p>
             <a:pPr lvl="0"/>
             <a:r>
-              <a:rPr lang="en-US" smtClean="0"/>
+              <a:rPr lang="en-US"/>
               <a:t>Click to edit Master text styles</a:t>
             </a:r>
           </a:p>
           <a:p>
             <a:pPr lvl="1"/>
             <a:r>
-              <a:rPr lang="en-US" smtClean="0"/>
+              <a:rPr lang="en-US"/>
               <a:t>Second level</a:t>
             </a:r>
           </a:p>
           <a:p>
             <a:pPr lvl="2"/>
             <a:r>
-              <a:rPr lang="en-US" smtClean="0"/>
+              <a:rPr lang="en-US"/>
               <a:t>Third level</a:t>
             </a:r>
           </a:p>
           <a:p>
             <a:pPr lvl="3"/>
             <a:r>
-              <a:rPr lang="en-US" smtClean="0"/>
+              <a:rPr lang="en-US"/>
               <a:t>Fourth level</a:t>
             </a:r>
           </a:p>
           <a:p>
             <a:pPr lvl="4"/>
             <a:r>
-              <a:rPr lang="en-US" smtClean="0"/>
+              <a:rPr lang="en-US"/>
               <a:t>Fifth level</a:t>
             </a:r>
-            <a:endParaRPr lang="en-US"/>
           </a:p>
         </p:txBody>
       </p:sp>
@@ -1671,7 +1673,7 @@
           <a:p>
             <a:pPr lvl="0"/>
             <a:r>
-              <a:rPr lang="en-US" smtClean="0"/>
+              <a:rPr lang="en-US"/>
               <a:t>Click to edit Master text styles</a:t>
             </a:r>
           </a:p>
@@ -1727,38 +1729,37 @@
           <a:p>
             <a:pPr lvl="0"/>
             <a:r>
-              <a:rPr lang="en-US" smtClean="0"/>
+              <a:rPr lang="en-US"/>
               <a:t>Click to edit Master text styles</a:t>
             </a:r>
           </a:p>
           <a:p>
             <a:pPr lvl="1"/>
             <a:r>
-              <a:rPr lang="en-US" smtClean="0"/>
+              <a:rPr lang="en-US"/>
               <a:t>Second level</a:t>
             </a:r>
           </a:p>
           <a:p>
             <a:pPr lvl="2"/>
             <a:r>
-              <a:rPr lang="en-US" smtClean="0"/>
+              <a:rPr lang="en-US"/>
               <a:t>Third level</a:t>
             </a:r>
           </a:p>
           <a:p>
             <a:pPr lvl="3"/>
             <a:r>
-              <a:rPr lang="en-US" smtClean="0"/>
+              <a:rPr lang="en-US"/>
               <a:t>Fourth level</a:t>
             </a:r>
           </a:p>
           <a:p>
             <a:pPr lvl="4"/>
             <a:r>
-              <a:rPr lang="en-US" smtClean="0"/>
+              <a:rPr lang="en-US"/>
               <a:t>Fifth level</a:t>
             </a:r>
-            <a:endParaRPr lang="en-US"/>
           </a:p>
         </p:txBody>
       </p:sp>
@@ -1779,7 +1780,7 @@
           <a:p>
             <a:fld id="{5BCAD085-E8A6-8845-BD4E-CB4CCA059FC4}" type="datetimeFigureOut">
               <a:rPr lang="en-US" smtClean="0"/>
-              <a:t>1/27/13</a:t>
+              <a:t>10/7/2026</a:t>
             </a:fld>
             <a:endParaRPr lang="en-US"/>
           </a:p>
@@ -1873,10 +1874,9 @@
           <a:lstStyle/>
           <a:p>
             <a:r>
-              <a:rPr lang="en-US" smtClean="0"/>
+              <a:rPr lang="en-US"/>
               <a:t>Click to edit Master title style</a:t>
             </a:r>
-            <a:endParaRPr lang="en-US"/>
           </a:p>
         </p:txBody>
       </p:sp>
@@ -1897,7 +1897,7 @@
           <a:p>
             <a:fld id="{5BCAD085-E8A6-8845-BD4E-CB4CCA059FC4}" type="datetimeFigureOut">
               <a:rPr lang="en-US" smtClean="0"/>
-              <a:t>1/27/13</a:t>
+              <a:t>10/7/2026</a:t>
             </a:fld>
             <a:endParaRPr lang="en-US"/>
           </a:p>
@@ -1992,7 +1992,7 @@
           <a:p>
             <a:fld id="{5BCAD085-E8A6-8845-BD4E-CB4CCA059FC4}" type="datetimeFigureOut">
               <a:rPr lang="en-US" smtClean="0"/>
-              <a:t>1/27/13</a:t>
+              <a:t>10/7/2026</a:t>
             </a:fld>
             <a:endParaRPr lang="en-US"/>
           </a:p>
@@ -2095,10 +2095,9 @@
           </a:lstStyle>
           <a:p>
             <a:r>
-              <a:rPr lang="en-US" smtClean="0"/>
+              <a:rPr lang="en-US"/>
               <a:t>Click to edit Master title style</a:t>
             </a:r>
-            <a:endParaRPr lang="en-US"/>
           </a:p>
         </p:txBody>
       </p:sp>
@@ -2152,38 +2151,37 @@
           <a:p>
             <a:pPr lvl="0"/>
             <a:r>
-              <a:rPr lang="en-US" smtClean="0"/>
+              <a:rPr lang="en-US"/>
               <a:t>Click to edit Master text styles</a:t>
             </a:r>
           </a:p>
           <a:p>
             <a:pPr lvl="1"/>
             <a:r>
-              <a:rPr lang="en-US" smtClean="0"/>
+              <a:rPr lang="en-US"/>
               <a:t>Second level</a:t>
             </a:r>
           </a:p>
           <a:p>
             <a:pPr lvl="2"/>
             <a:r>
-              <a:rPr lang="en-US" smtClean="0"/>
+              <a:rPr lang="en-US"/>
               <a:t>Third level</a:t>
             </a:r>
           </a:p>
           <a:p>
             <a:pPr lvl="3"/>
             <a:r>
-              <a:rPr lang="en-US" smtClean="0"/>
+              <a:rPr lang="en-US"/>
               <a:t>Fourth level</a:t>
             </a:r>
           </a:p>
           <a:p>
             <a:pPr lvl="4"/>
             <a:r>
-              <a:rPr lang="en-US" smtClean="0"/>
+              <a:rPr lang="en-US"/>
               <a:t>Fifth level</a:t>
             </a:r>
-            <a:endParaRPr lang="en-US"/>
           </a:p>
         </p:txBody>
       </p:sp>
@@ -2246,7 +2244,7 @@
           <a:p>
             <a:pPr lvl="0"/>
             <a:r>
-              <a:rPr lang="en-US" smtClean="0"/>
+              <a:rPr lang="en-US"/>
               <a:t>Click to edit Master text styles</a:t>
             </a:r>
           </a:p>
@@ -2269,7 +2267,7 @@
           <a:p>
             <a:fld id="{5BCAD085-E8A6-8845-BD4E-CB4CCA059FC4}" type="datetimeFigureOut">
               <a:rPr lang="en-US" smtClean="0"/>
-              <a:t>1/27/13</a:t>
+              <a:t>10/7/2026</a:t>
             </a:fld>
             <a:endParaRPr lang="en-US"/>
           </a:p>
@@ -2372,10 +2370,9 @@
           </a:lstStyle>
           <a:p>
             <a:r>
-              <a:rPr lang="en-US" smtClean="0"/>
+              <a:rPr lang="en-US"/>
               <a:t>Click to edit Master title style</a:t>
             </a:r>
-            <a:endParaRPr lang="en-US"/>
           </a:p>
         </p:txBody>
       </p:sp>
@@ -2499,7 +2496,7 @@
           <a:p>
             <a:pPr lvl="0"/>
             <a:r>
-              <a:rPr lang="en-US" smtClean="0"/>
+              <a:rPr lang="en-US"/>
               <a:t>Click to edit Master text styles</a:t>
             </a:r>
           </a:p>
@@ -2522,7 +2519,7 @@
           <a:p>
             <a:fld id="{5BCAD085-E8A6-8845-BD4E-CB4CCA059FC4}" type="datetimeFigureOut">
               <a:rPr lang="en-US" smtClean="0"/>
-              <a:t>1/27/13</a:t>
+              <a:t>10/7/2026</a:t>
             </a:fld>
             <a:endParaRPr lang="en-US"/>
           </a:p>
@@ -2631,10 +2628,9 @@
           <a:lstStyle/>
           <a:p>
             <a:r>
-              <a:rPr lang="en-US" smtClean="0"/>
+              <a:rPr lang="en-US"/>
               <a:t>Click to edit Master title style</a:t>
             </a:r>
-            <a:endParaRPr lang="en-US"/>
           </a:p>
         </p:txBody>
       </p:sp>
@@ -2665,38 +2661,37 @@
           <a:p>
             <a:pPr lvl="0"/>
             <a:r>
-              <a:rPr lang="en-US" smtClean="0"/>
+              <a:rPr lang="en-US"/>
               <a:t>Click to edit Master text styles</a:t>
             </a:r>
           </a:p>
           <a:p>
             <a:pPr lvl="1"/>
             <a:r>
-              <a:rPr lang="en-US" smtClean="0"/>
+              <a:rPr lang="en-US"/>
               <a:t>Second level</a:t>
             </a:r>
           </a:p>
           <a:p>
             <a:pPr lvl="2"/>
             <a:r>
-              <a:rPr lang="en-US" smtClean="0"/>
+              <a:rPr lang="en-US"/>
               <a:t>Third level</a:t>
             </a:r>
           </a:p>
           <a:p>
             <a:pPr lvl="3"/>
             <a:r>
-              <a:rPr lang="en-US" smtClean="0"/>
+              <a:rPr lang="en-US"/>
               <a:t>Fourth level</a:t>
             </a:r>
           </a:p>
           <a:p>
             <a:pPr lvl="4"/>
             <a:r>
-              <a:rPr lang="en-US" smtClean="0"/>
+              <a:rPr lang="en-US"/>
               <a:t>Fifth level</a:t>
             </a:r>
-            <a:endParaRPr lang="en-US"/>
           </a:p>
         </p:txBody>
       </p:sp>
@@ -2735,7 +2730,7 @@
           <a:p>
             <a:fld id="{5BCAD085-E8A6-8845-BD4E-CB4CCA059FC4}" type="datetimeFigureOut">
               <a:rPr lang="en-US" smtClean="0"/>
-              <a:t>1/27/13</a:t>
+              <a:t>10/7/2026</a:t>
             </a:fld>
             <a:endParaRPr lang="en-US"/>
           </a:p>
@@ -3094,7 +3089,7 @@
 </file>
 
 <file path=ppt/slides/slide1.xml><?xml version="1.0" encoding="utf-8"?>
-<p:sld xmlns:a="http://schemas.openxmlformats.org/drawingml/2006/main" xmlns:p="http://schemas.openxmlformats.org/presentationml/2006/main" xmlns:r="http://schemas.openxmlformats.org/officeDocument/2006/relationships">
+<p:sld xmlns:a="http://schemas.openxmlformats.org/drawingml/2006/main" xmlns:r="http://schemas.openxmlformats.org/officeDocument/2006/relationships" xmlns:p="http://schemas.openxmlformats.org/presentationml/2006/main">
   <p:cSld>
     <p:spTree>
       <p:nvGrpSpPr>
@@ -3102,7 +3097,14 @@
         <p:cNvGrpSpPr/>
         <p:nvPr/>
       </p:nvGrpSpPr>
-      <p:grpSpPr/>
+      <p:grpSpPr>
+        <a:xfrm>
+          <a:off x="0" y="0"/>
+          <a:ext cx="0" cy="0"/>
+          <a:chOff x="0" y="0"/>
+          <a:chExt cx="0" cy="0"/>
+        </a:xfrm>
+      </p:grpSpPr>
       <p:sp>
         <p:nvSpPr>
           <p:cNvPr id="2" name="Rectangle 1"/>
@@ -3143,6 +3145,7 @@
           <a:lstStyle/>
           <a:p>
             <a:pPr algn="ctr"/>
+            <a:endParaRPr/>
           </a:p>
         </p:txBody>
       </p:sp>
@@ -3186,6 +3189,7 @@
           <a:lstStyle/>
           <a:p>
             <a:pPr algn="ctr"/>
+            <a:endParaRPr/>
           </a:p>
         </p:txBody>
       </p:sp>
@@ -3198,7 +3202,7 @@
         <p:spPr>
           <a:xfrm>
             <a:off x="1280160" y="1371600"/>
-            <a:ext cx="9601200" cy="4114800"/>
+            <a:ext cx="9601200" cy="3093154"/>
           </a:xfrm>
           <a:prstGeom prst="rect">
             <a:avLst/>
@@ -3223,7 +3227,8 @@
               </a:defRPr>
             </a:pPr>
             <a:r>
-              <a:t>TUGAS BESAR ANALISIS DAN PENGUJIAN SISTEM</a:t>
+              <a:rPr dirty="0"/>
+              <a:t>TUGAS ANALISIS DAN PENGUJIAN SISTEM</a:t>
             </a:r>
           </a:p>
           <a:p>
@@ -3239,10 +3244,14 @@
               </a:defRPr>
             </a:pPr>
             <a:r>
+              <a:rPr dirty="0"/>
               <a:t>ROOT CAUSE ANALYSIS (RCA)</a:t>
             </a:r>
-            <a:br/>
-            <a:r>
+            <a:br>
+              <a:rPr dirty="0"/>
+            </a:br>
+            <a:r>
+              <a:rPr dirty="0"/>
               <a:t>&amp; DEFECT IDENTIFICATION</a:t>
             </a:r>
           </a:p>
@@ -3259,7 +3268,64 @@
               </a:defRPr>
             </a:pPr>
             <a:r>
-              <a:t>Studi Kasus Penemuan 3 Defect Kritis, Analisis 5-Whys, Diagram Fishbone, serta Verifikasi Perbaikan pada Mini E-Commerce Order System</a:t>
+              <a:rPr dirty="0"/>
+              <a:t>Studi </a:t>
+            </a:r>
+            <a:r>
+              <a:rPr dirty="0" err="1"/>
+              <a:t>Kasus</a:t>
+            </a:r>
+            <a:r>
+              <a:rPr dirty="0"/>
+              <a:t> </a:t>
+            </a:r>
+            <a:r>
+              <a:rPr dirty="0" err="1"/>
+              <a:t>Penemuan</a:t>
+            </a:r>
+            <a:r>
+              <a:rPr dirty="0"/>
+              <a:t> 3 Defect </a:t>
+            </a:r>
+            <a:r>
+              <a:rPr dirty="0" err="1"/>
+              <a:t>Kritis</a:t>
+            </a:r>
+            <a:r>
+              <a:rPr dirty="0"/>
+              <a:t>, </a:t>
+            </a:r>
+            <a:r>
+              <a:rPr dirty="0" err="1"/>
+              <a:t>Analisis</a:t>
+            </a:r>
+            <a:r>
+              <a:rPr dirty="0"/>
+              <a:t> 5-Whys, Diagram Fishbone, </a:t>
+            </a:r>
+            <a:r>
+              <a:rPr dirty="0" err="1"/>
+              <a:t>serta</a:t>
+            </a:r>
+            <a:r>
+              <a:rPr dirty="0"/>
+              <a:t> </a:t>
+            </a:r>
+            <a:r>
+              <a:rPr dirty="0" err="1"/>
+              <a:t>Verifikasi</a:t>
+            </a:r>
+            <a:r>
+              <a:rPr dirty="0"/>
+              <a:t> </a:t>
+            </a:r>
+            <a:r>
+              <a:rPr dirty="0" err="1"/>
+              <a:t>Perbaikan</a:t>
+            </a:r>
+            <a:r>
+              <a:rPr dirty="0"/>
+              <a:t> pada Mini E-Commerce Order System</a:t>
             </a:r>
           </a:p>
           <a:p>
@@ -3272,7 +3338,28 @@
               </a:defRPr>
             </a:pPr>
             <a:r>
-              <a:t>Disusun Oleh : Zainul Mutawakkil  |  NIM : 23EO10003</a:t>
+              <a:rPr dirty="0" err="1"/>
+              <a:t>Disusun</a:t>
+            </a:r>
+            <a:r>
+              <a:rPr dirty="0"/>
+              <a:t> Oleh : </a:t>
+            </a:r>
+            <a:r>
+              <a:rPr dirty="0" err="1"/>
+              <a:t>Zainul</a:t>
+            </a:r>
+            <a:r>
+              <a:rPr dirty="0"/>
+              <a:t> </a:t>
+            </a:r>
+            <a:r>
+              <a:rPr dirty="0" err="1"/>
+              <a:t>Mutawakkil</a:t>
+            </a:r>
+            <a:r>
+              <a:rPr dirty="0"/>
+              <a:t>  |  NIM : 23EO10003</a:t>
             </a:r>
           </a:p>
           <a:p>
@@ -3285,8 +3372,38 @@
               </a:defRPr>
             </a:pPr>
             <a:r>
-              <a:t>Mata Kuliah : Analisis dan Pengujian Sistem  •  Tahun Akademik 2026</a:t>
-            </a:r>
+              <a:rPr dirty="0"/>
+              <a:t>Mata </a:t>
+            </a:r>
+            <a:r>
+              <a:rPr dirty="0" err="1"/>
+              <a:t>Kuliah</a:t>
+            </a:r>
+            <a:r>
+              <a:rPr dirty="0"/>
+              <a:t> : </a:t>
+            </a:r>
+            <a:r>
+              <a:rPr dirty="0" err="1"/>
+              <a:t>Analisis</a:t>
+            </a:r>
+            <a:r>
+              <a:rPr dirty="0"/>
+              <a:t> dan </a:t>
+            </a:r>
+            <a:r>
+              <a:rPr dirty="0" err="1"/>
+              <a:t>Pengujian</a:t>
+            </a:r>
+            <a:r>
+              <a:rPr dirty="0"/>
+              <a:t> </a:t>
+            </a:r>
+            <a:r>
+              <a:rPr dirty="0" err="1"/>
+              <a:t>Sistem</a:t>
+            </a:r>
+            <a:endParaRPr dirty="0"/>
           </a:p>
         </p:txBody>
       </p:sp>
@@ -3299,7 +3416,7 @@
 </file>
 
 <file path=ppt/slides/slide10.xml><?xml version="1.0" encoding="utf-8"?>
-<p:sld xmlns:a="http://schemas.openxmlformats.org/drawingml/2006/main" xmlns:p="http://schemas.openxmlformats.org/presentationml/2006/main" xmlns:r="http://schemas.openxmlformats.org/officeDocument/2006/relationships">
+<p:sld xmlns:a="http://schemas.openxmlformats.org/drawingml/2006/main" xmlns:r="http://schemas.openxmlformats.org/officeDocument/2006/relationships" xmlns:p="http://schemas.openxmlformats.org/presentationml/2006/main">
   <p:cSld>
     <p:spTree>
       <p:nvGrpSpPr>
@@ -3307,7 +3424,14 @@
         <p:cNvGrpSpPr/>
         <p:nvPr/>
       </p:nvGrpSpPr>
-      <p:grpSpPr/>
+      <p:grpSpPr>
+        <a:xfrm>
+          <a:off x="0" y="0"/>
+          <a:ext cx="0" cy="0"/>
+          <a:chOff x="0" y="0"/>
+          <a:chExt cx="0" cy="0"/>
+        </a:xfrm>
+      </p:grpSpPr>
       <p:sp>
         <p:nvSpPr>
           <p:cNvPr id="2" name="Rectangle 1"/>
@@ -3348,6 +3472,7 @@
           <a:lstStyle/>
           <a:p>
             <a:pPr algn="ctr"/>
+            <a:endParaRPr/>
           </a:p>
         </p:txBody>
       </p:sp>
@@ -3481,6 +3606,7 @@
           <a:lstStyle/>
           <a:p>
             <a:pPr algn="ctr"/>
+            <a:endParaRPr/>
           </a:p>
         </p:txBody>
       </p:sp>
@@ -3501,7 +3627,7 @@
           <a:noFill/>
         </p:spPr>
         <p:txBody>
-          <a:bodyPr wrap="square" lIns="0" rIns="0" tIns="0" bIns="0">
+          <a:bodyPr wrap="square" lIns="0" tIns="0" rIns="0" bIns="0">
             <a:spAutoFit/>
           </a:bodyPr>
           <a:lstStyle/>
@@ -3655,6 +3781,7 @@
           <a:lstStyle/>
           <a:p>
             <a:pPr algn="ctr"/>
+            <a:endParaRPr/>
           </a:p>
         </p:txBody>
       </p:sp>
@@ -3675,7 +3802,7 @@
           <a:noFill/>
         </p:spPr>
         <p:txBody>
-          <a:bodyPr wrap="square" lIns="0" rIns="0" tIns="0" bIns="0">
+          <a:bodyPr wrap="square" lIns="0" tIns="0" rIns="0" bIns="0">
             <a:spAutoFit/>
           </a:bodyPr>
           <a:lstStyle/>
@@ -3705,6 +3832,7 @@
               <a:t>Hasil Eksekusi Unit Test Verifikasi:</a:t>
             </a:r>
             <a:br/>
+            <a:endParaRPr/>
           </a:p>
           <a:p>
             <a:pPr>
@@ -3829,7 +3957,7 @@
 </file>
 
 <file path=ppt/slides/slide11.xml><?xml version="1.0" encoding="utf-8"?>
-<p:sld xmlns:a="http://schemas.openxmlformats.org/drawingml/2006/main" xmlns:p="http://schemas.openxmlformats.org/presentationml/2006/main" xmlns:r="http://schemas.openxmlformats.org/officeDocument/2006/relationships">
+<p:sld xmlns:a="http://schemas.openxmlformats.org/drawingml/2006/main" xmlns:r="http://schemas.openxmlformats.org/officeDocument/2006/relationships" xmlns:p="http://schemas.openxmlformats.org/presentationml/2006/main">
   <p:cSld>
     <p:spTree>
       <p:nvGrpSpPr>
@@ -3837,7 +3965,14 @@
         <p:cNvGrpSpPr/>
         <p:nvPr/>
       </p:nvGrpSpPr>
-      <p:grpSpPr/>
+      <p:grpSpPr>
+        <a:xfrm>
+          <a:off x="0" y="0"/>
+          <a:ext cx="0" cy="0"/>
+          <a:chOff x="0" y="0"/>
+          <a:chExt cx="0" cy="0"/>
+        </a:xfrm>
+      </p:grpSpPr>
       <p:sp>
         <p:nvSpPr>
           <p:cNvPr id="2" name="Rectangle 1"/>
@@ -3878,6 +4013,7 @@
           <a:lstStyle/>
           <a:p>
             <a:pPr algn="ctr"/>
+            <a:endParaRPr/>
           </a:p>
         </p:txBody>
       </p:sp>
@@ -4011,6 +4147,7 @@
           <a:lstStyle/>
           <a:p>
             <a:pPr algn="ctr"/>
+            <a:endParaRPr/>
           </a:p>
         </p:txBody>
       </p:sp>
@@ -4031,7 +4168,7 @@
           <a:noFill/>
         </p:spPr>
         <p:txBody>
-          <a:bodyPr wrap="square" lIns="0" rIns="0" tIns="0" bIns="0">
+          <a:bodyPr wrap="square" lIns="0" tIns="0" rIns="0" bIns="0">
             <a:spAutoFit/>
           </a:bodyPr>
           <a:lstStyle/>
@@ -4203,6 +4340,7 @@
           <a:lstStyle/>
           <a:p>
             <a:pPr algn="ctr"/>
+            <a:endParaRPr/>
           </a:p>
         </p:txBody>
       </p:sp>
@@ -4223,7 +4361,7 @@
           <a:noFill/>
         </p:spPr>
         <p:txBody>
-          <a:bodyPr wrap="square" lIns="0" rIns="0" tIns="0" bIns="0">
+          <a:bodyPr wrap="square" lIns="0" tIns="0" rIns="0" bIns="0">
             <a:spAutoFit/>
           </a:bodyPr>
           <a:lstStyle/>
@@ -4345,7 +4483,7 @@
 </file>
 
 <file path=ppt/slides/slide12.xml><?xml version="1.0" encoding="utf-8"?>
-<p:sld xmlns:a="http://schemas.openxmlformats.org/drawingml/2006/main" xmlns:p="http://schemas.openxmlformats.org/presentationml/2006/main" xmlns:r="http://schemas.openxmlformats.org/officeDocument/2006/relationships">
+<p:sld xmlns:a="http://schemas.openxmlformats.org/drawingml/2006/main" xmlns:r="http://schemas.openxmlformats.org/officeDocument/2006/relationships" xmlns:p="http://schemas.openxmlformats.org/presentationml/2006/main">
   <p:cSld>
     <p:spTree>
       <p:nvGrpSpPr>
@@ -4353,7 +4491,14 @@
         <p:cNvGrpSpPr/>
         <p:nvPr/>
       </p:nvGrpSpPr>
-      <p:grpSpPr/>
+      <p:grpSpPr>
+        <a:xfrm>
+          <a:off x="0" y="0"/>
+          <a:ext cx="0" cy="0"/>
+          <a:chOff x="0" y="0"/>
+          <a:chExt cx="0" cy="0"/>
+        </a:xfrm>
+      </p:grpSpPr>
       <p:sp>
         <p:nvSpPr>
           <p:cNvPr id="2" name="Rectangle 1"/>
@@ -4394,6 +4539,7 @@
           <a:lstStyle/>
           <a:p>
             <a:pPr algn="ctr"/>
+            <a:endParaRPr/>
           </a:p>
         </p:txBody>
       </p:sp>
@@ -4527,6 +4673,7 @@
           <a:lstStyle/>
           <a:p>
             <a:pPr algn="ctr"/>
+            <a:endParaRPr/>
           </a:p>
         </p:txBody>
       </p:sp>
@@ -4547,7 +4694,7 @@
           <a:noFill/>
         </p:spPr>
         <p:txBody>
-          <a:bodyPr wrap="square" lIns="0" rIns="0" tIns="0" bIns="0">
+          <a:bodyPr wrap="square" lIns="0" tIns="0" rIns="0" bIns="0">
             <a:spAutoFit/>
           </a:bodyPr>
           <a:lstStyle/>
@@ -4756,6 +4903,7 @@
           <a:lstStyle/>
           <a:p>
             <a:pPr algn="ctr"/>
+            <a:endParaRPr/>
           </a:p>
         </p:txBody>
       </p:sp>
@@ -4776,7 +4924,7 @@
           <a:noFill/>
         </p:spPr>
         <p:txBody>
-          <a:bodyPr wrap="square" lIns="0" rIns="0" tIns="0" bIns="0">
+          <a:bodyPr wrap="square" lIns="0" tIns="0" rIns="0" bIns="0">
             <a:spAutoFit/>
           </a:bodyPr>
           <a:lstStyle/>
@@ -4923,7 +5071,7 @@
 </file>
 
 <file path=ppt/slides/slide13.xml><?xml version="1.0" encoding="utf-8"?>
-<p:sld xmlns:a="http://schemas.openxmlformats.org/drawingml/2006/main" xmlns:p="http://schemas.openxmlformats.org/presentationml/2006/main" xmlns:r="http://schemas.openxmlformats.org/officeDocument/2006/relationships">
+<p:sld xmlns:a="http://schemas.openxmlformats.org/drawingml/2006/main" xmlns:r="http://schemas.openxmlformats.org/officeDocument/2006/relationships" xmlns:p="http://schemas.openxmlformats.org/presentationml/2006/main">
   <p:cSld>
     <p:spTree>
       <p:nvGrpSpPr>
@@ -4931,7 +5079,14 @@
         <p:cNvGrpSpPr/>
         <p:nvPr/>
       </p:nvGrpSpPr>
-      <p:grpSpPr/>
+      <p:grpSpPr>
+        <a:xfrm>
+          <a:off x="0" y="0"/>
+          <a:ext cx="0" cy="0"/>
+          <a:chOff x="0" y="0"/>
+          <a:chExt cx="0" cy="0"/>
+        </a:xfrm>
+      </p:grpSpPr>
       <p:sp>
         <p:nvSpPr>
           <p:cNvPr id="2" name="Rectangle 1"/>
@@ -4972,6 +5127,7 @@
           <a:lstStyle/>
           <a:p>
             <a:pPr algn="ctr"/>
+            <a:endParaRPr/>
           </a:p>
         </p:txBody>
       </p:sp>
@@ -5105,6 +5261,7 @@
           <a:lstStyle/>
           <a:p>
             <a:pPr algn="ctr"/>
+            <a:endParaRPr/>
           </a:p>
         </p:txBody>
       </p:sp>
@@ -5125,7 +5282,7 @@
           <a:noFill/>
         </p:spPr>
         <p:txBody>
-          <a:bodyPr wrap="square" lIns="0" rIns="0" tIns="0" bIns="0">
+          <a:bodyPr wrap="square" lIns="0" tIns="0" rIns="0" bIns="0">
             <a:spAutoFit/>
           </a:bodyPr>
           <a:lstStyle/>
@@ -5292,6 +5449,7 @@
           <a:lstStyle/>
           <a:p>
             <a:pPr algn="ctr"/>
+            <a:endParaRPr/>
           </a:p>
         </p:txBody>
       </p:sp>
@@ -5312,7 +5470,7 @@
           <a:noFill/>
         </p:spPr>
         <p:txBody>
-          <a:bodyPr wrap="square" lIns="0" rIns="0" tIns="0" bIns="0">
+          <a:bodyPr wrap="square" lIns="0" tIns="0" rIns="0" bIns="0">
             <a:spAutoFit/>
           </a:bodyPr>
           <a:lstStyle/>
@@ -5342,6 +5500,7 @@
               <a:t>Hasil Eksekusi Unit Test Verifikasi:</a:t>
             </a:r>
             <a:br/>
+            <a:endParaRPr/>
           </a:p>
           <a:p>
             <a:pPr>
@@ -5482,7 +5641,7 @@
 </file>
 
 <file path=ppt/slides/slide14.xml><?xml version="1.0" encoding="utf-8"?>
-<p:sld xmlns:a="http://schemas.openxmlformats.org/drawingml/2006/main" xmlns:p="http://schemas.openxmlformats.org/presentationml/2006/main" xmlns:r="http://schemas.openxmlformats.org/officeDocument/2006/relationships">
+<p:sld xmlns:a="http://schemas.openxmlformats.org/drawingml/2006/main" xmlns:r="http://schemas.openxmlformats.org/officeDocument/2006/relationships" xmlns:p="http://schemas.openxmlformats.org/presentationml/2006/main">
   <p:cSld>
     <p:spTree>
       <p:nvGrpSpPr>
@@ -5490,7 +5649,14 @@
         <p:cNvGrpSpPr/>
         <p:nvPr/>
       </p:nvGrpSpPr>
-      <p:grpSpPr/>
+      <p:grpSpPr>
+        <a:xfrm>
+          <a:off x="0" y="0"/>
+          <a:ext cx="0" cy="0"/>
+          <a:chOff x="0" y="0"/>
+          <a:chExt cx="0" cy="0"/>
+        </a:xfrm>
+      </p:grpSpPr>
       <p:sp>
         <p:nvSpPr>
           <p:cNvPr id="2" name="Rectangle 1"/>
@@ -5531,6 +5697,7 @@
           <a:lstStyle/>
           <a:p>
             <a:pPr algn="ctr"/>
+            <a:endParaRPr/>
           </a:p>
         </p:txBody>
       </p:sp>
@@ -5641,10 +5808,34 @@
                 <a:tableStyleId>{5C22544A-7EE6-4342-B048-85BDC9FD1C3A}</a:tableStyleId>
               </a:tblPr>
               <a:tblGrid>
-                <a:gridCol w="1645920"/>
-                <a:gridCol w="2468880"/>
-                <a:gridCol w="3291840"/>
-                <a:gridCol w="3322015"/>
+                <a:gridCol w="1645920">
+                  <a:extLst>
+                    <a:ext uri="{9D8B030D-6E8A-4147-A177-3AD203B41FA5}">
+                      <a16:colId xmlns:a16="http://schemas.microsoft.com/office/drawing/2014/main" val="20000"/>
+                    </a:ext>
+                  </a:extLst>
+                </a:gridCol>
+                <a:gridCol w="2468880">
+                  <a:extLst>
+                    <a:ext uri="{9D8B030D-6E8A-4147-A177-3AD203B41FA5}">
+                      <a16:colId xmlns:a16="http://schemas.microsoft.com/office/drawing/2014/main" val="20001"/>
+                    </a:ext>
+                  </a:extLst>
+                </a:gridCol>
+                <a:gridCol w="3291840">
+                  <a:extLst>
+                    <a:ext uri="{9D8B030D-6E8A-4147-A177-3AD203B41FA5}">
+                      <a16:colId xmlns:a16="http://schemas.microsoft.com/office/drawing/2014/main" val="20002"/>
+                    </a:ext>
+                  </a:extLst>
+                </a:gridCol>
+                <a:gridCol w="3322015">
+                  <a:extLst>
+                    <a:ext uri="{9D8B030D-6E8A-4147-A177-3AD203B41FA5}">
+                      <a16:colId xmlns:a16="http://schemas.microsoft.com/office/drawing/2014/main" val="20003"/>
+                    </a:ext>
+                  </a:extLst>
+                </a:gridCol>
               </a:tblGrid>
               <a:tr h="1143000">
                 <a:tc>
@@ -5743,6 +5934,11 @@
                     </a:solidFill>
                   </a:tcPr>
                 </a:tc>
+                <a:extLst>
+                  <a:ext uri="{0D108BD9-81ED-4DB2-BD59-A6C34878D82A}">
+                    <a16:rowId xmlns:a16="http://schemas.microsoft.com/office/drawing/2014/main" val="10000"/>
+                  </a:ext>
+                </a:extLst>
               </a:tr>
               <a:tr h="1143000">
                 <a:tc>
@@ -5845,6 +6041,11 @@
                     </a:solidFill>
                   </a:tcPr>
                 </a:tc>
+                <a:extLst>
+                  <a:ext uri="{0D108BD9-81ED-4DB2-BD59-A6C34878D82A}">
+                    <a16:rowId xmlns:a16="http://schemas.microsoft.com/office/drawing/2014/main" val="10001"/>
+                  </a:ext>
+                </a:extLst>
               </a:tr>
               <a:tr h="1143000">
                 <a:tc>
@@ -5947,6 +6148,11 @@
                     </a:solidFill>
                   </a:tcPr>
                 </a:tc>
+                <a:extLst>
+                  <a:ext uri="{0D108BD9-81ED-4DB2-BD59-A6C34878D82A}">
+                    <a16:rowId xmlns:a16="http://schemas.microsoft.com/office/drawing/2014/main" val="10002"/>
+                  </a:ext>
+                </a:extLst>
               </a:tr>
               <a:tr h="1143000">
                 <a:tc>
@@ -6049,6 +6255,11 @@
                     </a:solidFill>
                   </a:tcPr>
                 </a:tc>
+                <a:extLst>
+                  <a:ext uri="{0D108BD9-81ED-4DB2-BD59-A6C34878D82A}">
+                    <a16:rowId xmlns:a16="http://schemas.microsoft.com/office/drawing/2014/main" val="10003"/>
+                  </a:ext>
+                </a:extLst>
               </a:tr>
             </a:tbl>
           </a:graphicData>
@@ -6063,7 +6274,7 @@
 </file>
 
 <file path=ppt/slides/slide15.xml><?xml version="1.0" encoding="utf-8"?>
-<p:sld xmlns:a="http://schemas.openxmlformats.org/drawingml/2006/main" xmlns:p="http://schemas.openxmlformats.org/presentationml/2006/main" xmlns:r="http://schemas.openxmlformats.org/officeDocument/2006/relationships">
+<p:sld xmlns:a="http://schemas.openxmlformats.org/drawingml/2006/main" xmlns:r="http://schemas.openxmlformats.org/officeDocument/2006/relationships" xmlns:p="http://schemas.openxmlformats.org/presentationml/2006/main">
   <p:cSld>
     <p:spTree>
       <p:nvGrpSpPr>
@@ -6071,7 +6282,14 @@
         <p:cNvGrpSpPr/>
         <p:nvPr/>
       </p:nvGrpSpPr>
-      <p:grpSpPr/>
+      <p:grpSpPr>
+        <a:xfrm>
+          <a:off x="0" y="0"/>
+          <a:ext cx="0" cy="0"/>
+          <a:chOff x="0" y="0"/>
+          <a:chExt cx="0" cy="0"/>
+        </a:xfrm>
+      </p:grpSpPr>
       <p:sp>
         <p:nvSpPr>
           <p:cNvPr id="2" name="Rectangle 1"/>
@@ -6112,6 +6330,7 @@
           <a:lstStyle/>
           <a:p>
             <a:pPr algn="ctr"/>
+            <a:endParaRPr/>
           </a:p>
         </p:txBody>
       </p:sp>
@@ -6245,6 +6464,7 @@
           <a:lstStyle/>
           <a:p>
             <a:pPr algn="ctr"/>
+            <a:endParaRPr/>
           </a:p>
         </p:txBody>
       </p:sp>
@@ -6265,7 +6485,7 @@
           <a:noFill/>
         </p:spPr>
         <p:txBody>
-          <a:bodyPr wrap="square" lIns="0" rIns="0" tIns="0" bIns="0">
+          <a:bodyPr wrap="square" lIns="0" tIns="0" rIns="0" bIns="0">
             <a:spAutoFit/>
           </a:bodyPr>
           <a:lstStyle/>
@@ -6342,6 +6562,7 @@
           <a:lstStyle/>
           <a:p>
             <a:pPr algn="ctr"/>
+            <a:endParaRPr/>
           </a:p>
         </p:txBody>
       </p:sp>
@@ -6362,7 +6583,7 @@
           <a:noFill/>
         </p:spPr>
         <p:txBody>
-          <a:bodyPr wrap="square" lIns="0" rIns="0" tIns="0" bIns="0">
+          <a:bodyPr wrap="square" lIns="0" tIns="0" rIns="0" bIns="0">
             <a:spAutoFit/>
           </a:bodyPr>
           <a:lstStyle/>
@@ -6439,6 +6660,7 @@
           <a:lstStyle/>
           <a:p>
             <a:pPr algn="ctr"/>
+            <a:endParaRPr/>
           </a:p>
         </p:txBody>
       </p:sp>
@@ -6459,7 +6681,7 @@
           <a:noFill/>
         </p:spPr>
         <p:txBody>
-          <a:bodyPr wrap="square" lIns="0" rIns="0" tIns="0" bIns="0">
+          <a:bodyPr wrap="square" lIns="0" tIns="0" rIns="0" bIns="0">
             <a:spAutoFit/>
           </a:bodyPr>
           <a:lstStyle/>
@@ -6536,6 +6758,7 @@
           <a:lstStyle/>
           <a:p>
             <a:pPr algn="ctr"/>
+            <a:endParaRPr/>
           </a:p>
         </p:txBody>
       </p:sp>
@@ -6556,7 +6779,7 @@
           <a:noFill/>
         </p:spPr>
         <p:txBody>
-          <a:bodyPr wrap="square" lIns="0" rIns="0" tIns="0" bIns="0">
+          <a:bodyPr wrap="square" lIns="0" tIns="0" rIns="0" bIns="0">
             <a:spAutoFit/>
           </a:bodyPr>
           <a:lstStyle/>
@@ -6600,7 +6823,7 @@
 </file>
 
 <file path=ppt/slides/slide16.xml><?xml version="1.0" encoding="utf-8"?>
-<p:sld xmlns:a="http://schemas.openxmlformats.org/drawingml/2006/main" xmlns:p="http://schemas.openxmlformats.org/presentationml/2006/main" xmlns:r="http://schemas.openxmlformats.org/officeDocument/2006/relationships">
+<p:sld xmlns:a="http://schemas.openxmlformats.org/drawingml/2006/main" xmlns:r="http://schemas.openxmlformats.org/officeDocument/2006/relationships" xmlns:p="http://schemas.openxmlformats.org/presentationml/2006/main">
   <p:cSld>
     <p:spTree>
       <p:nvGrpSpPr>
@@ -6608,7 +6831,14 @@
         <p:cNvGrpSpPr/>
         <p:nvPr/>
       </p:nvGrpSpPr>
-      <p:grpSpPr/>
+      <p:grpSpPr>
+        <a:xfrm>
+          <a:off x="0" y="0"/>
+          <a:ext cx="0" cy="0"/>
+          <a:chOff x="0" y="0"/>
+          <a:chExt cx="0" cy="0"/>
+        </a:xfrm>
+      </p:grpSpPr>
       <p:sp>
         <p:nvSpPr>
           <p:cNvPr id="2" name="Rectangle 1"/>
@@ -6649,6 +6879,7 @@
           <a:lstStyle/>
           <a:p>
             <a:pPr algn="ctr"/>
+            <a:endParaRPr/>
           </a:p>
         </p:txBody>
       </p:sp>
@@ -6692,6 +6923,7 @@
           <a:lstStyle/>
           <a:p>
             <a:pPr algn="ctr"/>
+            <a:endParaRPr/>
           </a:p>
         </p:txBody>
       </p:sp>
@@ -6782,17 +7014,6 @@
           </a:p>
           <a:p>
             <a:br/>
-            <a:pPr>
-              <a:spcAft>
-                <a:spcPts val="600"/>
-              </a:spcAft>
-              <a:defRPr sz="2400" b="1">
-                <a:solidFill>
-                  <a:srgbClr val="FFFFFF"/>
-                </a:solidFill>
-                <a:latin typeface="Segoe UI"/>
-              </a:defRPr>
-            </a:pPr>
             <a:r>
               <a:t>TERIMA KASIH — SESI TANYA JAWAB (Q &amp; A)</a:t>
             </a:r>
@@ -6821,7 +7042,7 @@
 </file>
 
 <file path=ppt/slides/slide2.xml><?xml version="1.0" encoding="utf-8"?>
-<p:sld xmlns:a="http://schemas.openxmlformats.org/drawingml/2006/main" xmlns:p="http://schemas.openxmlformats.org/presentationml/2006/main" xmlns:r="http://schemas.openxmlformats.org/officeDocument/2006/relationships">
+<p:sld xmlns:a="http://schemas.openxmlformats.org/drawingml/2006/main" xmlns:r="http://schemas.openxmlformats.org/officeDocument/2006/relationships" xmlns:p="http://schemas.openxmlformats.org/presentationml/2006/main">
   <p:cSld>
     <p:spTree>
       <p:nvGrpSpPr>
@@ -6829,7 +7050,14 @@
         <p:cNvGrpSpPr/>
         <p:nvPr/>
       </p:nvGrpSpPr>
-      <p:grpSpPr/>
+      <p:grpSpPr>
+        <a:xfrm>
+          <a:off x="0" y="0"/>
+          <a:ext cx="0" cy="0"/>
+          <a:chOff x="0" y="0"/>
+          <a:chExt cx="0" cy="0"/>
+        </a:xfrm>
+      </p:grpSpPr>
       <p:sp>
         <p:nvSpPr>
           <p:cNvPr id="2" name="Rectangle 1"/>
@@ -6870,6 +7098,7 @@
           <a:lstStyle/>
           <a:p>
             <a:pPr algn="ctr"/>
+            <a:endParaRPr/>
           </a:p>
         </p:txBody>
       </p:sp>
@@ -7003,6 +7232,7 @@
           <a:lstStyle/>
           <a:p>
             <a:pPr algn="ctr"/>
+            <a:endParaRPr/>
           </a:p>
         </p:txBody>
       </p:sp>
@@ -7023,7 +7253,7 @@
           <a:noFill/>
         </p:spPr>
         <p:txBody>
-          <a:bodyPr wrap="square" lIns="0" rIns="0" tIns="0" bIns="0">
+          <a:bodyPr wrap="square" lIns="0" tIns="0" rIns="0" bIns="0">
             <a:spAutoFit/>
           </a:bodyPr>
           <a:lstStyle/>
@@ -7100,6 +7330,7 @@
           <a:lstStyle/>
           <a:p>
             <a:pPr algn="ctr"/>
+            <a:endParaRPr/>
           </a:p>
         </p:txBody>
       </p:sp>
@@ -7120,7 +7351,7 @@
           <a:noFill/>
         </p:spPr>
         <p:txBody>
-          <a:bodyPr wrap="square" lIns="0" rIns="0" tIns="0" bIns="0">
+          <a:bodyPr wrap="square" lIns="0" tIns="0" rIns="0" bIns="0">
             <a:spAutoFit/>
           </a:bodyPr>
           <a:lstStyle/>
@@ -7197,6 +7428,7 @@
           <a:lstStyle/>
           <a:p>
             <a:pPr algn="ctr"/>
+            <a:endParaRPr/>
           </a:p>
         </p:txBody>
       </p:sp>
@@ -7217,7 +7449,7 @@
           <a:noFill/>
         </p:spPr>
         <p:txBody>
-          <a:bodyPr wrap="square" lIns="0" rIns="0" tIns="0" bIns="0">
+          <a:bodyPr wrap="square" lIns="0" tIns="0" rIns="0" bIns="0">
             <a:spAutoFit/>
           </a:bodyPr>
           <a:lstStyle/>
@@ -7294,6 +7526,7 @@
           <a:lstStyle/>
           <a:p>
             <a:pPr algn="ctr"/>
+            <a:endParaRPr/>
           </a:p>
         </p:txBody>
       </p:sp>
@@ -7314,7 +7547,7 @@
           <a:noFill/>
         </p:spPr>
         <p:txBody>
-          <a:bodyPr wrap="square" lIns="0" rIns="0" tIns="0" bIns="0">
+          <a:bodyPr wrap="square" lIns="0" tIns="0" rIns="0" bIns="0">
             <a:spAutoFit/>
           </a:bodyPr>
           <a:lstStyle/>
@@ -7391,6 +7624,7 @@
           <a:lstStyle/>
           <a:p>
             <a:pPr algn="ctr"/>
+            <a:endParaRPr/>
           </a:p>
         </p:txBody>
       </p:sp>
@@ -7411,7 +7645,7 @@
           <a:noFill/>
         </p:spPr>
         <p:txBody>
-          <a:bodyPr wrap="square" lIns="0" rIns="0" tIns="0" bIns="0">
+          <a:bodyPr wrap="square" lIns="0" tIns="0" rIns="0" bIns="0">
             <a:spAutoFit/>
           </a:bodyPr>
           <a:lstStyle/>
@@ -7439,7 +7673,7 @@
 </file>
 
 <file path=ppt/slides/slide3.xml><?xml version="1.0" encoding="utf-8"?>
-<p:sld xmlns:a="http://schemas.openxmlformats.org/drawingml/2006/main" xmlns:p="http://schemas.openxmlformats.org/presentationml/2006/main" xmlns:r="http://schemas.openxmlformats.org/officeDocument/2006/relationships">
+<p:sld xmlns:a="http://schemas.openxmlformats.org/drawingml/2006/main" xmlns:r="http://schemas.openxmlformats.org/officeDocument/2006/relationships" xmlns:p="http://schemas.openxmlformats.org/presentationml/2006/main">
   <p:cSld>
     <p:spTree>
       <p:nvGrpSpPr>
@@ -7447,7 +7681,14 @@
         <p:cNvGrpSpPr/>
         <p:nvPr/>
       </p:nvGrpSpPr>
-      <p:grpSpPr/>
+      <p:grpSpPr>
+        <a:xfrm>
+          <a:off x="0" y="0"/>
+          <a:ext cx="0" cy="0"/>
+          <a:chOff x="0" y="0"/>
+          <a:chExt cx="0" cy="0"/>
+        </a:xfrm>
+      </p:grpSpPr>
       <p:sp>
         <p:nvSpPr>
           <p:cNvPr id="2" name="Rectangle 1"/>
@@ -7488,6 +7729,7 @@
           <a:lstStyle/>
           <a:p>
             <a:pPr algn="ctr"/>
+            <a:endParaRPr/>
           </a:p>
         </p:txBody>
       </p:sp>
@@ -7621,6 +7863,7 @@
           <a:lstStyle/>
           <a:p>
             <a:pPr algn="ctr"/>
+            <a:endParaRPr/>
           </a:p>
         </p:txBody>
       </p:sp>
@@ -7641,7 +7884,7 @@
           <a:noFill/>
         </p:spPr>
         <p:txBody>
-          <a:bodyPr wrap="square" lIns="0" rIns="0" tIns="0" bIns="0">
+          <a:bodyPr wrap="square" lIns="0" tIns="0" rIns="0" bIns="0">
             <a:spAutoFit/>
           </a:bodyPr>
           <a:lstStyle/>
@@ -7833,6 +8076,7 @@
           <a:lstStyle/>
           <a:p>
             <a:pPr algn="ctr"/>
+            <a:endParaRPr/>
           </a:p>
         </p:txBody>
       </p:sp>
@@ -7853,7 +8097,7 @@
           <a:noFill/>
         </p:spPr>
         <p:txBody>
-          <a:bodyPr wrap="square" lIns="0" rIns="0" tIns="0" bIns="0">
+          <a:bodyPr wrap="square" lIns="0" tIns="0" rIns="0" bIns="0">
             <a:spAutoFit/>
           </a:bodyPr>
           <a:lstStyle/>
@@ -7996,7 +8240,7 @@
 </file>
 
 <file path=ppt/slides/slide4.xml><?xml version="1.0" encoding="utf-8"?>
-<p:sld xmlns:a="http://schemas.openxmlformats.org/drawingml/2006/main" xmlns:p="http://schemas.openxmlformats.org/presentationml/2006/main" xmlns:r="http://schemas.openxmlformats.org/officeDocument/2006/relationships">
+<p:sld xmlns:a="http://schemas.openxmlformats.org/drawingml/2006/main" xmlns:r="http://schemas.openxmlformats.org/officeDocument/2006/relationships" xmlns:p="http://schemas.openxmlformats.org/presentationml/2006/main">
   <p:cSld>
     <p:spTree>
       <p:nvGrpSpPr>
@@ -8004,7 +8248,14 @@
         <p:cNvGrpSpPr/>
         <p:nvPr/>
       </p:nvGrpSpPr>
-      <p:grpSpPr/>
+      <p:grpSpPr>
+        <a:xfrm>
+          <a:off x="0" y="0"/>
+          <a:ext cx="0" cy="0"/>
+          <a:chOff x="0" y="0"/>
+          <a:chExt cx="0" cy="0"/>
+        </a:xfrm>
+      </p:grpSpPr>
       <p:sp>
         <p:nvSpPr>
           <p:cNvPr id="2" name="Rectangle 1"/>
@@ -8045,6 +8296,7 @@
           <a:lstStyle/>
           <a:p>
             <a:pPr algn="ctr"/>
+            <a:endParaRPr/>
           </a:p>
         </p:txBody>
       </p:sp>
@@ -8178,6 +8430,7 @@
           <a:lstStyle/>
           <a:p>
             <a:pPr algn="ctr"/>
+            <a:endParaRPr/>
           </a:p>
         </p:txBody>
       </p:sp>
@@ -8198,7 +8451,7 @@
           <a:noFill/>
         </p:spPr>
         <p:txBody>
-          <a:bodyPr wrap="square" lIns="0" rIns="0" tIns="0" bIns="0">
+          <a:bodyPr wrap="square" lIns="0" tIns="0" rIns="0" bIns="0">
             <a:spAutoFit/>
           </a:bodyPr>
           <a:lstStyle/>
@@ -8357,6 +8610,7 @@
           <a:lstStyle/>
           <a:p>
             <a:pPr algn="ctr"/>
+            <a:endParaRPr/>
           </a:p>
         </p:txBody>
       </p:sp>
@@ -8377,7 +8631,7 @@
           <a:noFill/>
         </p:spPr>
         <p:txBody>
-          <a:bodyPr wrap="square" lIns="0" rIns="0" tIns="0" bIns="0">
+          <a:bodyPr wrap="square" lIns="0" tIns="0" rIns="0" bIns="0">
             <a:spAutoFit/>
           </a:bodyPr>
           <a:lstStyle/>
@@ -8536,6 +8790,7 @@
           <a:lstStyle/>
           <a:p>
             <a:pPr algn="ctr"/>
+            <a:endParaRPr/>
           </a:p>
         </p:txBody>
       </p:sp>
@@ -8556,7 +8811,7 @@
           <a:noFill/>
         </p:spPr>
         <p:txBody>
-          <a:bodyPr wrap="square" lIns="0" rIns="0" tIns="0" bIns="0">
+          <a:bodyPr wrap="square" lIns="0" tIns="0" rIns="0" bIns="0">
             <a:spAutoFit/>
           </a:bodyPr>
           <a:lstStyle/>
@@ -8682,7 +8937,7 @@
 </file>
 
 <file path=ppt/slides/slide5.xml><?xml version="1.0" encoding="utf-8"?>
-<p:sld xmlns:a="http://schemas.openxmlformats.org/drawingml/2006/main" xmlns:p="http://schemas.openxmlformats.org/presentationml/2006/main" xmlns:r="http://schemas.openxmlformats.org/officeDocument/2006/relationships">
+<p:sld xmlns:a="http://schemas.openxmlformats.org/drawingml/2006/main" xmlns:r="http://schemas.openxmlformats.org/officeDocument/2006/relationships" xmlns:p="http://schemas.openxmlformats.org/presentationml/2006/main">
   <p:cSld>
     <p:spTree>
       <p:nvGrpSpPr>
@@ -8690,7 +8945,14 @@
         <p:cNvGrpSpPr/>
         <p:nvPr/>
       </p:nvGrpSpPr>
-      <p:grpSpPr/>
+      <p:grpSpPr>
+        <a:xfrm>
+          <a:off x="0" y="0"/>
+          <a:ext cx="0" cy="0"/>
+          <a:chOff x="0" y="0"/>
+          <a:chExt cx="0" cy="0"/>
+        </a:xfrm>
+      </p:grpSpPr>
       <p:sp>
         <p:nvSpPr>
           <p:cNvPr id="2" name="Rectangle 1"/>
@@ -8731,6 +8993,7 @@
           <a:lstStyle/>
           <a:p>
             <a:pPr algn="ctr"/>
+            <a:endParaRPr/>
           </a:p>
         </p:txBody>
       </p:sp>
@@ -8864,6 +9127,7 @@
           <a:lstStyle/>
           <a:p>
             <a:pPr algn="ctr"/>
+            <a:endParaRPr/>
           </a:p>
         </p:txBody>
       </p:sp>
@@ -8884,7 +9148,7 @@
           <a:noFill/>
         </p:spPr>
         <p:txBody>
-          <a:bodyPr wrap="square" lIns="0" rIns="0" tIns="0" bIns="0">
+          <a:bodyPr wrap="square" lIns="0" tIns="0" rIns="0" bIns="0">
             <a:spAutoFit/>
           </a:bodyPr>
           <a:lstStyle/>
@@ -8984,14 +9248,6 @@
           </a:p>
           <a:p>
             <a:br/>
-            <a:pPr>
-              <a:defRPr sz="1000">
-                <a:solidFill>
-                  <a:srgbClr val="DC2626"/>
-                </a:solidFill>
-                <a:latin typeface="Consolas"/>
-              </a:defRPr>
-            </a:pPr>
             <a:r>
               <a:t>Log Hasil Test Runner:</a:t>
             </a:r>
@@ -9056,6 +9312,7 @@
           <a:lstStyle/>
           <a:p>
             <a:pPr algn="ctr"/>
+            <a:endParaRPr/>
           </a:p>
         </p:txBody>
       </p:sp>
@@ -9076,7 +9333,7 @@
           <a:noFill/>
         </p:spPr>
         <p:txBody>
-          <a:bodyPr wrap="square" lIns="0" rIns="0" tIns="0" bIns="0">
+          <a:bodyPr wrap="square" lIns="0" tIns="0" rIns="0" bIns="0">
             <a:spAutoFit/>
           </a:bodyPr>
           <a:lstStyle/>
@@ -9185,7 +9442,7 @@
 </file>
 
 <file path=ppt/slides/slide6.xml><?xml version="1.0" encoding="utf-8"?>
-<p:sld xmlns:a="http://schemas.openxmlformats.org/drawingml/2006/main" xmlns:p="http://schemas.openxmlformats.org/presentationml/2006/main" xmlns:r="http://schemas.openxmlformats.org/officeDocument/2006/relationships">
+<p:sld xmlns:a="http://schemas.openxmlformats.org/drawingml/2006/main" xmlns:r="http://schemas.openxmlformats.org/officeDocument/2006/relationships" xmlns:p="http://schemas.openxmlformats.org/presentationml/2006/main">
   <p:cSld>
     <p:spTree>
       <p:nvGrpSpPr>
@@ -9193,7 +9450,14 @@
         <p:cNvGrpSpPr/>
         <p:nvPr/>
       </p:nvGrpSpPr>
-      <p:grpSpPr/>
+      <p:grpSpPr>
+        <a:xfrm>
+          <a:off x="0" y="0"/>
+          <a:ext cx="0" cy="0"/>
+          <a:chOff x="0" y="0"/>
+          <a:chExt cx="0" cy="0"/>
+        </a:xfrm>
+      </p:grpSpPr>
       <p:sp>
         <p:nvSpPr>
           <p:cNvPr id="2" name="Rectangle 1"/>
@@ -9234,6 +9498,7 @@
           <a:lstStyle/>
           <a:p>
             <a:pPr algn="ctr"/>
+            <a:endParaRPr/>
           </a:p>
         </p:txBody>
       </p:sp>
@@ -9367,6 +9632,7 @@
           <a:lstStyle/>
           <a:p>
             <a:pPr algn="ctr"/>
+            <a:endParaRPr/>
           </a:p>
         </p:txBody>
       </p:sp>
@@ -9387,7 +9653,7 @@
           <a:noFill/>
         </p:spPr>
         <p:txBody>
-          <a:bodyPr wrap="square" lIns="0" rIns="0" tIns="0" bIns="0">
+          <a:bodyPr wrap="square" lIns="0" tIns="0" rIns="0" bIns="0">
             <a:spAutoFit/>
           </a:bodyPr>
           <a:lstStyle/>
@@ -9596,6 +9862,7 @@
           <a:lstStyle/>
           <a:p>
             <a:pPr algn="ctr"/>
+            <a:endParaRPr/>
           </a:p>
         </p:txBody>
       </p:sp>
@@ -9616,7 +9883,7 @@
           <a:noFill/>
         </p:spPr>
         <p:txBody>
-          <a:bodyPr wrap="square" lIns="0" rIns="0" tIns="0" bIns="0">
+          <a:bodyPr wrap="square" lIns="0" tIns="0" rIns="0" bIns="0">
             <a:spAutoFit/>
           </a:bodyPr>
           <a:lstStyle/>
@@ -9763,7 +10030,7 @@
 </file>
 
 <file path=ppt/slides/slide7.xml><?xml version="1.0" encoding="utf-8"?>
-<p:sld xmlns:a="http://schemas.openxmlformats.org/drawingml/2006/main" xmlns:p="http://schemas.openxmlformats.org/presentationml/2006/main" xmlns:r="http://schemas.openxmlformats.org/officeDocument/2006/relationships">
+<p:sld xmlns:a="http://schemas.openxmlformats.org/drawingml/2006/main" xmlns:r="http://schemas.openxmlformats.org/officeDocument/2006/relationships" xmlns:p="http://schemas.openxmlformats.org/presentationml/2006/main">
   <p:cSld>
     <p:spTree>
       <p:nvGrpSpPr>
@@ -9771,7 +10038,14 @@
         <p:cNvGrpSpPr/>
         <p:nvPr/>
       </p:nvGrpSpPr>
-      <p:grpSpPr/>
+      <p:grpSpPr>
+        <a:xfrm>
+          <a:off x="0" y="0"/>
+          <a:ext cx="0" cy="0"/>
+          <a:chOff x="0" y="0"/>
+          <a:chExt cx="0" cy="0"/>
+        </a:xfrm>
+      </p:grpSpPr>
       <p:sp>
         <p:nvSpPr>
           <p:cNvPr id="2" name="Rectangle 1"/>
@@ -9812,6 +10086,7 @@
           <a:lstStyle/>
           <a:p>
             <a:pPr algn="ctr"/>
+            <a:endParaRPr/>
           </a:p>
         </p:txBody>
       </p:sp>
@@ -9945,6 +10220,7 @@
           <a:lstStyle/>
           <a:p>
             <a:pPr algn="ctr"/>
+            <a:endParaRPr/>
           </a:p>
         </p:txBody>
       </p:sp>
@@ -9965,7 +10241,7 @@
           <a:noFill/>
         </p:spPr>
         <p:txBody>
-          <a:bodyPr wrap="square" lIns="0" rIns="0" tIns="0" bIns="0">
+          <a:bodyPr wrap="square" lIns="0" tIns="0" rIns="0" bIns="0">
             <a:spAutoFit/>
           </a:bodyPr>
           <a:lstStyle/>
@@ -10107,6 +10383,7 @@
           <a:lstStyle/>
           <a:p>
             <a:pPr algn="ctr"/>
+            <a:endParaRPr/>
           </a:p>
         </p:txBody>
       </p:sp>
@@ -10127,7 +10404,7 @@
           <a:noFill/>
         </p:spPr>
         <p:txBody>
-          <a:bodyPr wrap="square" lIns="0" rIns="0" tIns="0" bIns="0">
+          <a:bodyPr wrap="square" lIns="0" tIns="0" rIns="0" bIns="0">
             <a:spAutoFit/>
           </a:bodyPr>
           <a:lstStyle/>
@@ -10157,6 +10434,7 @@
               <a:t>Hasil Eksekusi Unit Test Verifikasi:</a:t>
             </a:r>
             <a:br/>
+            <a:endParaRPr/>
           </a:p>
           <a:p>
             <a:pPr>
@@ -10265,7 +10543,7 @@
 </file>
 
 <file path=ppt/slides/slide8.xml><?xml version="1.0" encoding="utf-8"?>
-<p:sld xmlns:a="http://schemas.openxmlformats.org/drawingml/2006/main" xmlns:p="http://schemas.openxmlformats.org/presentationml/2006/main" xmlns:r="http://schemas.openxmlformats.org/officeDocument/2006/relationships">
+<p:sld xmlns:a="http://schemas.openxmlformats.org/drawingml/2006/main" xmlns:r="http://schemas.openxmlformats.org/officeDocument/2006/relationships" xmlns:p="http://schemas.openxmlformats.org/presentationml/2006/main">
   <p:cSld>
     <p:spTree>
       <p:nvGrpSpPr>
@@ -10273,7 +10551,14 @@
         <p:cNvGrpSpPr/>
         <p:nvPr/>
       </p:nvGrpSpPr>
-      <p:grpSpPr/>
+      <p:grpSpPr>
+        <a:xfrm>
+          <a:off x="0" y="0"/>
+          <a:ext cx="0" cy="0"/>
+          <a:chOff x="0" y="0"/>
+          <a:chExt cx="0" cy="0"/>
+        </a:xfrm>
+      </p:grpSpPr>
       <p:sp>
         <p:nvSpPr>
           <p:cNvPr id="2" name="Rectangle 1"/>
@@ -10314,6 +10599,7 @@
           <a:lstStyle/>
           <a:p>
             <a:pPr algn="ctr"/>
+            <a:endParaRPr/>
           </a:p>
         </p:txBody>
       </p:sp>
@@ -10447,6 +10733,7 @@
           <a:lstStyle/>
           <a:p>
             <a:pPr algn="ctr"/>
+            <a:endParaRPr/>
           </a:p>
         </p:txBody>
       </p:sp>
@@ -10467,7 +10754,7 @@
           <a:noFill/>
         </p:spPr>
         <p:txBody>
-          <a:bodyPr wrap="square" lIns="0" rIns="0" tIns="0" bIns="0">
+          <a:bodyPr wrap="square" lIns="0" tIns="0" rIns="0" bIns="0">
             <a:spAutoFit/>
           </a:bodyPr>
           <a:lstStyle/>
@@ -10606,6 +10893,7 @@
           <a:lstStyle/>
           <a:p>
             <a:pPr algn="ctr"/>
+            <a:endParaRPr/>
           </a:p>
         </p:txBody>
       </p:sp>
@@ -10626,7 +10914,7 @@
           <a:noFill/>
         </p:spPr>
         <p:txBody>
-          <a:bodyPr wrap="square" lIns="0" rIns="0" tIns="0" bIns="0">
+          <a:bodyPr wrap="square" lIns="0" tIns="0" rIns="0" bIns="0">
             <a:spAutoFit/>
           </a:bodyPr>
           <a:lstStyle/>
@@ -10739,7 +11027,7 @@
 </file>
 
 <file path=ppt/slides/slide9.xml><?xml version="1.0" encoding="utf-8"?>
-<p:sld xmlns:a="http://schemas.openxmlformats.org/drawingml/2006/main" xmlns:p="http://schemas.openxmlformats.org/presentationml/2006/main" xmlns:r="http://schemas.openxmlformats.org/officeDocument/2006/relationships">
+<p:sld xmlns:a="http://schemas.openxmlformats.org/drawingml/2006/main" xmlns:r="http://schemas.openxmlformats.org/officeDocument/2006/relationships" xmlns:p="http://schemas.openxmlformats.org/presentationml/2006/main">
   <p:cSld>
     <p:spTree>
       <p:nvGrpSpPr>
@@ -10747,7 +11035,14 @@
         <p:cNvGrpSpPr/>
         <p:nvPr/>
       </p:nvGrpSpPr>
-      <p:grpSpPr/>
+      <p:grpSpPr>
+        <a:xfrm>
+          <a:off x="0" y="0"/>
+          <a:ext cx="0" cy="0"/>
+          <a:chOff x="0" y="0"/>
+          <a:chExt cx="0" cy="0"/>
+        </a:xfrm>
+      </p:grpSpPr>
       <p:sp>
         <p:nvSpPr>
           <p:cNvPr id="2" name="Rectangle 1"/>
@@ -10788,6 +11083,7 @@
           <a:lstStyle/>
           <a:p>
             <a:pPr algn="ctr"/>
+            <a:endParaRPr/>
           </a:p>
         </p:txBody>
       </p:sp>
@@ -10921,6 +11217,7 @@
           <a:lstStyle/>
           <a:p>
             <a:pPr algn="ctr"/>
+            <a:endParaRPr/>
           </a:p>
         </p:txBody>
       </p:sp>
@@ -10941,7 +11238,7 @@
           <a:noFill/>
         </p:spPr>
         <p:txBody>
-          <a:bodyPr wrap="square" lIns="0" rIns="0" tIns="0" bIns="0">
+          <a:bodyPr wrap="square" lIns="0" tIns="0" rIns="0" bIns="0">
             <a:spAutoFit/>
           </a:bodyPr>
           <a:lstStyle/>
@@ -11150,6 +11447,7 @@
           <a:lstStyle/>
           <a:p>
             <a:pPr algn="ctr"/>
+            <a:endParaRPr/>
           </a:p>
         </p:txBody>
       </p:sp>
@@ -11170,7 +11468,7 @@
           <a:noFill/>
         </p:spPr>
         <p:txBody>
-          <a:bodyPr wrap="square" lIns="0" rIns="0" tIns="0" bIns="0">
+          <a:bodyPr wrap="square" lIns="0" tIns="0" rIns="0" bIns="0">
             <a:spAutoFit/>
           </a:bodyPr>
           <a:lstStyle/>

</xml_diff>